<commit_message>
Mute lower/moderate 3D extrusions; add live URL to docs and deck
Extrusions can't vary opacity per feature, so the 3D risk view now uses
dark tints for lower/moderate cells to keep high/critical hotspots
dominant. README, presentation script and pitch deck link to
https://heatshield26.vercel.app.

Co-Authored-By: Claude Opus 5 <noreply@anthropic.com>
</commit_message>
<xml_diff>
--- a/docs/HeatShield26-Pitch.pptx
+++ b/docs/HeatShield26-Pitch.pptx
@@ -4191,8 +4191,8 @@
         </p:nvSpPr>
         <p:spPr>
           <a:xfrm>
-            <a:off x="7315200" y="5577840"/>
-            <a:ext cx="4389120" cy="457200"/>
+            <a:off x="7315200" y="5440680"/>
+            <a:ext cx="4389120" cy="731520"/>
           </a:xfrm>
           <a:prstGeom prst="rect">
             <a:avLst/>
@@ -4209,6 +4209,23 @@
             </a:pPr>
             <a:r>
               <a:rPr lang="en-US" sz="1500" b="1" dirty="0">
+                <a:solidFill>
+                  <a:srgbClr val="FF7A1A"/>
+                </a:solidFill>
+                <a:latin typeface="Calibri" pitchFamily="34" charset="0"/>
+                <a:ea typeface="Calibri" pitchFamily="34" charset="-122"/>
+                <a:cs typeface="Calibri" pitchFamily="34" charset="-120"/>
+              </a:rPr>
+              <a:t>heatshield26.vercel.app</a:t>
+            </a:r>
+            <a:endParaRPr lang="en-US" sz="1500" dirty="0"/>
+          </a:p>
+          <a:p>
+            <a:pPr indent="0" marL="0">
+              <a:buNone/>
+            </a:pPr>
+            <a:r>
+              <a:rPr lang="en-US" sz="1500" dirty="0">
                 <a:solidFill>
                   <a:srgbClr val="E8EDF2"/>
                 </a:solidFill>
@@ -4517,8 +4534,8 @@
         </p:nvSpPr>
         <p:spPr>
           <a:xfrm>
-            <a:off x="548640" y="5897880"/>
-            <a:ext cx="5852160" cy="365760"/>
+            <a:off x="548640" y="5577840"/>
+            <a:ext cx="5852160" cy="731520"/>
           </a:xfrm>
           <a:prstGeom prst="rect">
             <a:avLst/>
@@ -4529,6 +4546,23 @@
         <p:txBody>
           <a:bodyPr wrap="square" lIns="0" tIns="0" rIns="0" bIns="0" rtlCol="0" anchor="ctr"/>
           <a:lstStyle/>
+          <a:p>
+            <a:pPr indent="0" marL="0">
+              <a:buNone/>
+            </a:pPr>
+            <a:r>
+              <a:rPr lang="en-US" sz="1400" b="1" dirty="0">
+                <a:solidFill>
+                  <a:srgbClr val="FF7A1A"/>
+                </a:solidFill>
+                <a:latin typeface="Calibri" pitchFamily="34" charset="0"/>
+                <a:ea typeface="Calibri" pitchFamily="34" charset="-122"/>
+                <a:cs typeface="Calibri" pitchFamily="34" charset="-120"/>
+              </a:rPr>
+              <a:t>Try it: heatshield26.vercel.app</a:t>
+            </a:r>
+            <a:endParaRPr lang="en-US" sz="1400" dirty="0"/>
+          </a:p>
           <a:p>
             <a:pPr indent="0" marL="0">
               <a:buNone/>

</xml_diff>

<commit_message>
Update pitch deck for the Houston-wide rebuild and add a combined submission video
Refreshes the pitch deck (numbers, chart data, and NRG-only framing) to
match the final multi-venue dataset: 3 -> 0 critical zones, 17,109 -> 0
visitors, -10.2% for $990K, 3,434 hex cells, and calls out the 6-venue
generalization on the demo and impact slides. Mirrors the same fixes
into PRESENTATION_SCRIPT.md.

Adds docs/social/full-video.mp4: a single combined submission video
that narrates the title/problem/solution/model slides, cuts into the
real live-app demo footage (replacing the old static "live demo"
screenshot slides), then narrates the data-rigor/impact/tech/close
slides -- built from PowerPoint-exported slide images, edge-tts
narration per slide, and ffmpeg concatenation with demo-full.mp4.

Co-Authored-By: Claude Sonnet 5 <noreply@anthropic.com>
</commit_message>
<xml_diff>
--- a/docs/HeatShield26-Pitch.pptx
+++ b/docs/HeatShield26-Pitch.pptx
@@ -199,10 +199,10 @@
                 <c:formatCode>General</c:formatCode>
                 <c:ptCount val="2"/>
                 <c:pt idx="0">
-                  <c:v>5</c:v>
+                  <c:v>3</c:v>
                 </c:pt>
                 <c:pt idx="1">
-                  <c:v>74</c:v>
+                  <c:v>196</c:v>
                 </c:pt>
               </c:numCache>
             </c:numRef>
@@ -279,7 +279,7 @@
                   <c:v>0</c:v>
                 </c:pt>
                 <c:pt idx="1">
-                  <c:v>56</c:v>
+                  <c:v>179</c:v>
                 </c:pt>
               </c:numCache>
             </c:numRef>
@@ -924,7 +924,7 @@
             <a:r>
               <a:rPr lang="en-US" dirty="0"/>
               <a:t>[~25 sec]
-Why does this matter beyond the World Cup? The tournament is over — but NRG Park hosts the Rodeo and Texans games every year, and Houston's heat season gets longer.
+Why does this matter beyond the World Cup? The tournament is over — but NRG Park hosts the Rodeo and Texans games every year, Houston has five other major venues, and the heat season gets longer.
 It's feasible today: it only uses data Houston already publishes, it recommends things a city can actually buy, and it runs in a browser. And every cooling hub placed for one event becomes a resilience hub for the neighborhood next door.</a:t>
             </a:r>
             <a:endParaRPr lang="en-US" dirty="0"/>
@@ -1465,8 +1465,8 @@
               <a:rPr lang="en-US" dirty="0"/>
               <a:t>[~25 sec]
 HeatShield does four things.
-One — it measures: we pulled eleven open datasets and joined them onto about fourteen hundred hexagons, each about a tenth of a square kilometer.
-Two — it models the crowd: attendance gets routed from the actual rail stations and the actual NRG parking lots, weighted by their real capacities.
+One — it measures: we pulled eleven open datasets and joined them onto about thirty-four hundred hexagons across Houston inside Loop 610.
+Two — it models the crowd: attendance gets routed from the actual rail stations and each venue's own nearby lots and garages, weighted by their real or estimated capacities.
 Three — it scores risk for every cell. Four — it helps you act: place interventions yourself or give it a budget.
 And it's transparent — no black-box AI deciding where the money goes.</a:t>
             </a:r>
@@ -1648,8 +1648,8 @@
               <a:rPr lang="en-US" dirty="0"/>
               <a:t>[SWITCH TO THE LIVE APP — ~45 sec. If Wi-Fi fails, stay on this slide and narrate the screenshot.]
 This is the planner. Sixty-eight thousand attendees, ninety-eight degrees, afternoon kickoff.
-Red is critical. Notice it isn't the whole city — it's the NRG parking lots right at the stadium edge, where people tailgate on asphalt, and the rail stations where fans queue. Five critical zones, seventy-nine high-risk zones, and almost nineteen thousand visitors whose route crosses a critical zone.
-[Drag temperature to 88] Watch — at eighty-eight degrees the critical zones disappear. [Back to 98.] [Click 3D] The height is risk. [Switch layer to Crowd, show routes] And these are the routes we model — rail, parking, rideshare, walk-ups.</a:t>
+Red is critical. Notice it isn't the whole city — it's the parking lots right at the stadium edge, where people tailgate on asphalt, and the rail stations where fans queue. Three critical zones, about two hundred high-risk zones, and just over seventeen thousand visitors whose route crosses a critical zone.
+[Drag temperature to 88] Watch — at eighty-eight degrees the critical zones disappear. [Back to 98.] [Click 3D] The height is risk. [Switch the venue dropdown to Toyota Center, back to NRG] Same pipeline, six real Houston venues.</a:t>
             </a:r>
             <a:endParaRPr lang="en-US" dirty="0"/>
           </a:p>
@@ -1738,7 +1738,7 @@
             <a:r>
               <a:rPr lang="en-US" dirty="0"/>
               <a:t>[In the app: click the #1 zone — ~30 sec]
-Click any zone and HeatShield shows why. This cell scores seventy-nine. Crowd exposure is maxed — about fifty-four hundred person-hours. Two percent tree canopy. A hundred-and-twelve-degree heat index. And the nearest cooling center is more than a mile away.
+Click any zone and HeatShield shows why. This cell scores seventy-seven. Crowd exposure is near max — about forty-seven hundred person-hours. Two percent tree canopy. A hundred-and-twelve-degree heat index. And the nearest cooling center is more than a mile away.
 [Click Explain this recommendation] This is the only place we use AI. Gemini turns these exact numbers into a short memo a planner could paste into a briefing. It's told to use only these facts — the scores themselves are deterministic code.</a:t>
             </a:r>
             <a:endParaRPr lang="en-US" dirty="0"/>
@@ -1829,8 +1829,8 @@
               <a:rPr lang="en-US" dirty="0"/>
               <a:t>[In the app: Optimize tab → Optimize $1M plan — ~40 sec. This is the money moment; pause after clicking.]
 Knowing where the problem is isn't enough — cities need to know what to do. So I give it the budget: one million dollars.
-[Click] In about a tenth of a second it evaluates over eleven thousand options and builds a portfolio: water and misting stations, shade over the queues, a cooling hub, a shuttle loop.
-Critical zones go from five to zero. Visitors routed through critical zones go from nearly nineteen thousand to zero. Total exposure burden drops eighteen percent — for nine hundred eighty thousand dollars.
+[Click] In about a tenth of a second it evaluates over ten thousand options and builds a portfolio: mostly water and misting stations, plus shade over the queues, a cooling hub, and a shuttle loop.
+Critical zones go from three to zero. Visitors routed through critical zones go from seventeen thousand to zero. Total exposure burden drops about ten percent — for nine hundred ninety thousand dollars.
 The costs and effect sizes are planning assumptions, and they're labeled that way — a city would swap in its real procurement numbers.</a:t>
             </a:r>
             <a:endParaRPr lang="en-US" dirty="0"/>
@@ -2506,7 +2506,7 @@
                 <a:ea typeface="Calibri" pitchFamily="34" charset="-122"/>
                 <a:cs typeface="Calibri" pitchFamily="34" charset="-120"/>
               </a:rPr>
-              <a:t>A geospatial decision-support platform for NRG Park and its visitor corridors</a:t>
+              <a:t>A geospatial decision-support platform for Houston inside Loop 610 — 6 real venues, one model</a:t>
             </a:r>
             <a:endParaRPr lang="en-US" sz="1700" dirty="0"/>
           </a:p>
@@ -3192,7 +3192,7 @@
                 <a:ea typeface="Calibri" pitchFamily="34" charset="-122"/>
                 <a:cs typeface="Calibri" pitchFamily="34" charset="-120"/>
               </a:rPr>
-              <a:t>Texans games and the Rodeo at NRG Park</a:t>
+              <a:t>NRG, Daikin Park, Toyota Center, Shell Energy, TDECU &amp; Rice — one model, live today</a:t>
             </a:r>
             <a:endParaRPr lang="en-US" sz="1500" dirty="0"/>
           </a:p>
@@ -3273,7 +3273,7 @@
                 <a:ea typeface="Calibri" pitchFamily="34" charset="-122"/>
                 <a:cs typeface="Calibri" pitchFamily="34" charset="-120"/>
               </a:rPr>
-              <a:t>Swap the venue, attendance and arrival assumptions — the same pipeline plans the next event.</a:t>
+              <a:t>Pick the venue, attendance and arrival assumptions — the same pipeline already plans events at 6 real Houston venues.</a:t>
             </a:r>
             <a:endParaRPr lang="en-US" sz="1700" dirty="0"/>
           </a:p>
@@ -5321,7 +5321,7 @@
                 <a:ea typeface="Calibri" pitchFamily="34" charset="-122"/>
                 <a:cs typeface="Calibri" pitchFamily="34" charset="-120"/>
               </a:rPr>
-              <a:t>Adequate inside NRG Park’s open lots; coarse outside it.</a:t>
+              <a:t>Adequate inside each venue’s open lots; coarse outside them.</a:t>
             </a:r>
             <a:endParaRPr lang="en-US" sz="1400" dirty="0"/>
           </a:p>
@@ -7323,7 +7323,7 @@
                 <a:ea typeface="Calibri" pitchFamily="34" charset="-122"/>
                 <a:cs typeface="Calibri" pitchFamily="34" charset="-120"/>
               </a:rPr>
-              <a:t>11 open datasets joined onto 1,419 hex cells around NRG, Midtown and Downtown</a:t>
+              <a:t>11 open datasets joined onto 3,434 hex cells across Houston inside Loop 610</a:t>
             </a:r>
             <a:endParaRPr lang="en-US" sz="1400" dirty="0"/>
           </a:p>
@@ -9928,7 +9928,7 @@
                 <a:ea typeface="Calibri" pitchFamily="34" charset="-122"/>
                 <a:cs typeface="Calibri" pitchFamily="34" charset="-120"/>
               </a:rPr>
-              <a:t>5</a:t>
+              <a:t>3</a:t>
             </a:r>
             <a:endParaRPr lang="en-US" sz="3600" dirty="0"/>
           </a:p>
@@ -9967,7 +9967,7 @@
                 <a:ea typeface="Calibri" pitchFamily="34" charset="-122"/>
                 <a:cs typeface="Calibri" pitchFamily="34" charset="-120"/>
               </a:rPr>
-              <a:t>critical zones — on NRG Park’s Yellow, Green, Purple &amp; Teal lots at the stadium edge</a:t>
+              <a:t>critical zones — in the South Main and Astrodome Area parking fields at the stadium edge</a:t>
             </a:r>
             <a:endParaRPr lang="en-US" sz="1400" dirty="0"/>
           </a:p>
@@ -10006,7 +10006,7 @@
                 <a:ea typeface="Calibri" pitchFamily="34" charset="-122"/>
                 <a:cs typeface="Calibri" pitchFamily="34" charset="-120"/>
               </a:rPr>
-              <a:t>79</a:t>
+              <a:t>199</a:t>
             </a:r>
             <a:endParaRPr lang="en-US" sz="3600" dirty="0"/>
           </a:p>
@@ -10084,7 +10084,7 @@
                 <a:ea typeface="Calibri" pitchFamily="34" charset="-122"/>
                 <a:cs typeface="Calibri" pitchFamily="34" charset="-120"/>
               </a:rPr>
-              <a:t>18,978</a:t>
+              <a:t>17,109</a:t>
             </a:r>
             <a:endParaRPr lang="en-US" sz="3600" dirty="0"/>
           </a:p>
@@ -10242,7 +10242,7 @@
                 <a:ea typeface="Calibri" pitchFamily="34" charset="-122"/>
                 <a:cs typeface="Calibri" pitchFamily="34" charset="-120"/>
               </a:rPr>
-              <a:t>drag the temperature to 88°F (risk collapses), back to 98°F; toggle 3D; switch the layer to Crowd and show modeled routes.</a:t>
+              <a:t>drag the temperature to 88°F (risk collapses), back to 98°F; toggle 3D; switch the venue dropdown to show it generalizes to 5 other Houston venues.</a:t>
             </a:r>
             <a:endParaRPr lang="en-US" sz="1400" dirty="0"/>
           </a:p>
@@ -10530,7 +10530,7 @@
                 <a:ea typeface="Calibri" pitchFamily="34" charset="-122"/>
                 <a:cs typeface="Calibri" pitchFamily="34" charset="-120"/>
               </a:rPr>
-              <a:t>Crowd exposure 100/100</a:t>
+              <a:t>Crowd exposure 99/100</a:t>
             </a:r>
             <a:endParaRPr lang="en-US" sz="1700" dirty="0"/>
           </a:p>
@@ -10569,7 +10569,7 @@
                 <a:ea typeface="Calibri" pitchFamily="34" charset="-122"/>
                 <a:cs typeface="Calibri" pitchFamily="34" charset="-120"/>
               </a:rPr>
-              <a:t>≈5,400 event person-hours in one cell</a:t>
+              <a:t>≈4,751 event person-hours in one cell</a:t>
             </a:r>
             <a:endParaRPr lang="en-US" sz="1300" dirty="0"/>
           </a:p>
@@ -11069,7 +11069,7 @@
                 <a:ea typeface="Calibri" pitchFamily="34" charset="-122"/>
                 <a:cs typeface="Calibri" pitchFamily="34" charset="-120"/>
               </a:rPr>
-              <a:t>Example: South Main cell on NRG Park lots — risk 79, critical</a:t>
+              <a:t>Example: South Main cell on NRG Park lots — risk 77, critical</a:t>
             </a:r>
             <a:endParaRPr lang="en-US" sz="1100" dirty="0"/>
           </a:p>
@@ -11335,7 +11335,7 @@
                 <a:ea typeface="Calibri" pitchFamily="34" charset="-122"/>
                 <a:cs typeface="Calibri" pitchFamily="34" charset="-120"/>
               </a:rPr>
-              <a:t>5  </a:t>
+              <a:t>3  </a:t>
             </a:r>
             <a:pPr indent="0" marL="0">
               <a:buNone/>
@@ -11468,7 +11468,7 @@
                 <a:ea typeface="Calibri" pitchFamily="34" charset="-122"/>
                 <a:cs typeface="Calibri" pitchFamily="34" charset="-120"/>
               </a:rPr>
-              <a:t>18,978  </a:t>
+              <a:t>17,109  </a:t>
             </a:r>
             <a:pPr indent="0" marL="0">
               <a:buNone/>
@@ -11601,7 +11601,7 @@
                 <a:ea typeface="Calibri" pitchFamily="34" charset="-122"/>
                 <a:cs typeface="Calibri" pitchFamily="34" charset="-120"/>
               </a:rPr>
-              <a:t>−18%</a:t>
+              <a:t>−10.2%</a:t>
             </a:r>
             <a:endParaRPr lang="en-US" sz="3400" dirty="0"/>
           </a:p>
@@ -11640,7 +11640,7 @@
                 <a:ea typeface="Calibri" pitchFamily="34" charset="-122"/>
                 <a:cs typeface="Calibri" pitchFamily="34" charset="-120"/>
               </a:rPr>
-              <a:t>exposure burden for $980K (19 interventions)</a:t>
+              <a:t>exposure burden for $990K (18 interventions)</a:t>
             </a:r>
             <a:endParaRPr lang="en-US" sz="1400" dirty="0"/>
           </a:p>

</xml_diff>